<commit_message>
We get an MTL result!
</commit_message>
<xml_diff>
--- a/docs/DistRep_Dec3.pptx
+++ b/docs/DistRep_Dec3.pptx
@@ -213,7 +213,7 @@
           <a:p>
             <a:fld id="{C57F6EB1-A955-467E-AC9E-AC5540CA929F}" type="datetimeFigureOut">
               <a:rPr lang="en-US" smtClean="0"/>
-              <a:t>12/3/2023</a:t>
+              <a:t>4/2/2024</a:t>
             </a:fld>
             <a:endParaRPr lang="en-US"/>
           </a:p>
@@ -1125,7 +1125,7 @@
           <a:p>
             <a:fld id="{826B2E29-6454-4170-AF87-B006FFB35D00}" type="datetimeFigureOut">
               <a:rPr lang="en-US" smtClean="0"/>
-              <a:t>12/3/2023</a:t>
+              <a:t>4/2/2024</a:t>
             </a:fld>
             <a:endParaRPr lang="en-US" dirty="0"/>
           </a:p>
@@ -1323,7 +1323,7 @@
           <a:p>
             <a:fld id="{826B2E29-6454-4170-AF87-B006FFB35D00}" type="datetimeFigureOut">
               <a:rPr lang="en-US" smtClean="0"/>
-              <a:t>12/3/2023</a:t>
+              <a:t>4/2/2024</a:t>
             </a:fld>
             <a:endParaRPr lang="en-US"/>
           </a:p>
@@ -1531,7 +1531,7 @@
           <a:p>
             <a:fld id="{826B2E29-6454-4170-AF87-B006FFB35D00}" type="datetimeFigureOut">
               <a:rPr lang="en-US" smtClean="0"/>
-              <a:t>12/3/2023</a:t>
+              <a:t>4/2/2024</a:t>
             </a:fld>
             <a:endParaRPr lang="en-US"/>
           </a:p>
@@ -1775,7 +1775,7 @@
           <a:p>
             <a:fld id="{826B2E29-6454-4170-AF87-B006FFB35D00}" type="datetimeFigureOut">
               <a:rPr lang="en-US" smtClean="0"/>
-              <a:t>12/3/2023</a:t>
+              <a:t>4/2/2024</a:t>
             </a:fld>
             <a:endParaRPr lang="en-US"/>
           </a:p>
@@ -2050,7 +2050,7 @@
           <a:p>
             <a:fld id="{826B2E29-6454-4170-AF87-B006FFB35D00}" type="datetimeFigureOut">
               <a:rPr lang="en-US" smtClean="0"/>
-              <a:t>12/3/2023</a:t>
+              <a:t>4/2/2024</a:t>
             </a:fld>
             <a:endParaRPr lang="en-US"/>
           </a:p>
@@ -2315,7 +2315,7 @@
           <a:p>
             <a:fld id="{826B2E29-6454-4170-AF87-B006FFB35D00}" type="datetimeFigureOut">
               <a:rPr lang="en-US" smtClean="0"/>
-              <a:t>12/3/2023</a:t>
+              <a:t>4/2/2024</a:t>
             </a:fld>
             <a:endParaRPr lang="en-US"/>
           </a:p>
@@ -2727,7 +2727,7 @@
           <a:p>
             <a:fld id="{826B2E29-6454-4170-AF87-B006FFB35D00}" type="datetimeFigureOut">
               <a:rPr lang="en-US" smtClean="0"/>
-              <a:t>12/3/2023</a:t>
+              <a:t>4/2/2024</a:t>
             </a:fld>
             <a:endParaRPr lang="en-US"/>
           </a:p>
@@ -2868,7 +2868,7 @@
           <a:p>
             <a:fld id="{826B2E29-6454-4170-AF87-B006FFB35D00}" type="datetimeFigureOut">
               <a:rPr lang="en-US" smtClean="0"/>
-              <a:t>12/3/2023</a:t>
+              <a:t>4/2/2024</a:t>
             </a:fld>
             <a:endParaRPr lang="en-US"/>
           </a:p>
@@ -2981,7 +2981,7 @@
           <a:p>
             <a:fld id="{826B2E29-6454-4170-AF87-B006FFB35D00}" type="datetimeFigureOut">
               <a:rPr lang="en-US" smtClean="0"/>
-              <a:t>12/3/2023</a:t>
+              <a:t>4/2/2024</a:t>
             </a:fld>
             <a:endParaRPr lang="en-US"/>
           </a:p>
@@ -3292,7 +3292,7 @@
           <a:p>
             <a:fld id="{826B2E29-6454-4170-AF87-B006FFB35D00}" type="datetimeFigureOut">
               <a:rPr lang="en-US" smtClean="0"/>
-              <a:t>12/3/2023</a:t>
+              <a:t>4/2/2024</a:t>
             </a:fld>
             <a:endParaRPr lang="en-US"/>
           </a:p>
@@ -3583,7 +3583,7 @@
           <a:p>
             <a:fld id="{826B2E29-6454-4170-AF87-B006FFB35D00}" type="datetimeFigureOut">
               <a:rPr lang="en-US" smtClean="0"/>
-              <a:t>12/3/2023</a:t>
+              <a:t>4/2/2024</a:t>
             </a:fld>
             <a:endParaRPr lang="en-US"/>
           </a:p>
@@ -3826,7 +3826,7 @@
           <a:p>
             <a:fld id="{826B2E29-6454-4170-AF87-B006FFB35D00}" type="datetimeFigureOut">
               <a:rPr lang="en-US" smtClean="0"/>
-              <a:t>12/3/2023</a:t>
+              <a:t>4/2/2024</a:t>
             </a:fld>
             <a:endParaRPr lang="en-US"/>
           </a:p>
@@ -23998,7 +23998,7 @@
             <a:avLst/>
           </a:prstGeom>
           <a:solidFill>
-            <a:schemeClr val="tx1"/>
+            <a:srgbClr val="00B0F0"/>
           </a:solidFill>
           <a:ln>
             <a:solidFill>

</xml_diff>